<commit_message>
New Tech Stack Picture
</commit_message>
<xml_diff>
--- a/OOBA/Test_Kitchen_OOBA_12082026.pptx
+++ b/OOBA/Test_Kitchen_OOBA_12082026.pptx
@@ -12848,10 +12848,10 @@
 </file>
 
 <file path=customXml/item1.xml><?xml version="1.0" encoding="utf-8"?>
-<ct:contentTypeSchema xmlns:ct="http://schemas.microsoft.com/office/2006/metadata/contentType" xmlns:ma="http://schemas.microsoft.com/office/2006/metadata/properties/metaAttributes" ct:_="" ma:_="" ma:contentTypeName="Document" ma:contentTypeID="0x01010057A5EFB6AC14FB4185F753ADE2FBBD8E" ma:contentTypeVersion="16" ma:contentTypeDescription="Create a new document." ma:contentTypeScope="" ma:versionID="3d54870faaa681fd9102955c05c72dd5">
-  <xsd:schema xmlns:xsd="http://www.w3.org/2001/XMLSchema" xmlns:xs="http://www.w3.org/2001/XMLSchema" xmlns:p="http://schemas.microsoft.com/office/2006/metadata/properties" xmlns:ns2="4d3ef53e-8156-4ea7-b096-a070a847f892" xmlns:ns3="40f00ef8-db8f-4715-8532-1d4398c0116e" targetNamespace="http://schemas.microsoft.com/office/2006/metadata/properties" ma:root="true" ma:fieldsID="6c2fa08afd0c47f08d1b5ec367a4104f" ns2:_="" ns3:_="">
-    <xsd:import namespace="4d3ef53e-8156-4ea7-b096-a070a847f892"/>
-    <xsd:import namespace="40f00ef8-db8f-4715-8532-1d4398c0116e"/>
+<ct:contentTypeSchema xmlns:ct="http://schemas.microsoft.com/office/2006/metadata/contentType" xmlns:ma="http://schemas.microsoft.com/office/2006/metadata/properties/metaAttributes" ct:_="" ma:_="" ma:contentTypeName="Document" ma:contentTypeID="0x0101008D7A22E85D508D4BA3D88F285A4BFBFF" ma:contentTypeVersion="12" ma:contentTypeDescription="Create a new document." ma:contentTypeScope="" ma:versionID="9987cb3c740d251d46b9333d08217780">
+  <xsd:schema xmlns:xsd="http://www.w3.org/2001/XMLSchema" xmlns:xs="http://www.w3.org/2001/XMLSchema" xmlns:p="http://schemas.microsoft.com/office/2006/metadata/properties" xmlns:ns2="4aba8e23-181e-4a95-9270-5fdb07633be2" xmlns:ns3="5b5294e1-9b14-479f-be65-1200265709b9" targetNamespace="http://schemas.microsoft.com/office/2006/metadata/properties" ma:root="true" ma:fieldsID="5a731378c195bae6e936e83aa8f38fa1" ns2:_="" ns3:_="">
+    <xsd:import namespace="4aba8e23-181e-4a95-9270-5fdb07633be2"/>
+    <xsd:import namespace="5b5294e1-9b14-479f-be65-1200265709b9"/>
     <xsd:element name="properties">
       <xsd:complexType>
         <xsd:sequence>
@@ -12861,17 +12861,14 @@
                 <xsd:element ref="ns2:MediaServiceMetadata" minOccurs="0"/>
                 <xsd:element ref="ns2:MediaServiceFastMetadata" minOccurs="0"/>
                 <xsd:element ref="ns2:MediaServiceSearchProperties" minOccurs="0"/>
-                <xsd:element ref="ns2:MediaServiceObjectDetectorVersions" minOccurs="0"/>
+                <xsd:element ref="ns2:MediaServiceDateTaken" minOccurs="0"/>
                 <xsd:element ref="ns2:lcf76f155ced4ddcb4097134ff3c332f" minOccurs="0"/>
                 <xsd:element ref="ns3:TaxCatchAll" minOccurs="0"/>
-                <xsd:element ref="ns2:MediaServiceDateTaken" minOccurs="0"/>
                 <xsd:element ref="ns2:MediaServiceOCR" minOccurs="0"/>
                 <xsd:element ref="ns2:MediaServiceGenerationTime" minOccurs="0"/>
                 <xsd:element ref="ns2:MediaServiceEventHashCode" minOccurs="0"/>
+                <xsd:element ref="ns2:InformationClassification" minOccurs="0"/>
                 <xsd:element ref="ns2:MediaLengthInSeconds" minOccurs="0"/>
-                <xsd:element ref="ns2:MediaServiceBillingMetadata" minOccurs="0"/>
-                <xsd:element ref="ns2:MediaServiceLocation" minOccurs="0"/>
-                <xsd:element ref="ns2:InformationClassification" minOccurs="0"/>
               </xsd:all>
             </xsd:complexType>
           </xsd:element>
@@ -12879,7 +12876,7 @@
       </xsd:complexType>
     </xsd:element>
   </xsd:schema>
-  <xsd:schema xmlns:xsd="http://www.w3.org/2001/XMLSchema" xmlns:xs="http://www.w3.org/2001/XMLSchema" xmlns:dms="http://schemas.microsoft.com/office/2006/documentManagement/types" xmlns:pc="http://schemas.microsoft.com/office/infopath/2007/PartnerControls" targetNamespace="4d3ef53e-8156-4ea7-b096-a070a847f892" elementFormDefault="qualified">
+  <xsd:schema xmlns:xsd="http://www.w3.org/2001/XMLSchema" xmlns:xs="http://www.w3.org/2001/XMLSchema" xmlns:dms="http://schemas.microsoft.com/office/2006/documentManagement/types" xmlns:pc="http://schemas.microsoft.com/office/infopath/2007/PartnerControls" targetNamespace="4aba8e23-181e-4a95-9270-5fdb07633be2" elementFormDefault="qualified">
     <xsd:import namespace="http://schemas.microsoft.com/office/2006/documentManagement/types"/>
     <xsd:import namespace="http://schemas.microsoft.com/office/infopath/2007/PartnerControls"/>
     <xsd:element name="MediaServiceMetadata" ma:index="8" nillable="true" ma:displayName="MediaServiceMetadata" ma:hidden="true" ma:internalName="MediaServiceMetadata" ma:readOnly="true">
@@ -12897,7 +12894,7 @@
         <xsd:restriction base="dms:Note"/>
       </xsd:simpleType>
     </xsd:element>
-    <xsd:element name="MediaServiceObjectDetectorVersions" ma:index="11" nillable="true" ma:displayName="MediaServiceObjectDetectorVersions" ma:hidden="true" ma:indexed="true" ma:internalName="MediaServiceObjectDetectorVersions" ma:readOnly="true">
+    <xsd:element name="MediaServiceDateTaken" ma:index="11" nillable="true" ma:displayName="MediaServiceDateTaken" ma:hidden="true" ma:indexed="true" ma:internalName="MediaServiceDateTaken" ma:readOnly="true">
       <xsd:simpleType>
         <xsd:restriction base="dms:Text"/>
       </xsd:simpleType>
@@ -12909,26 +12906,30 @@
         </xsd:sequence>
       </xsd:complexType>
     </xsd:element>
-    <xsd:element name="MediaServiceDateTaken" ma:index="15" nillable="true" ma:displayName="MediaServiceDateTaken" ma:hidden="true" ma:indexed="true" ma:internalName="MediaServiceDateTaken" ma:readOnly="true">
-      <xsd:simpleType>
-        <xsd:restriction base="dms:Text"/>
-      </xsd:simpleType>
-    </xsd:element>
-    <xsd:element name="MediaServiceOCR" ma:index="16" nillable="true" ma:displayName="Extracted Text" ma:internalName="MediaServiceOCR" ma:readOnly="true">
+    <xsd:element name="MediaServiceOCR" ma:index="15" nillable="true" ma:displayName="Extracted Text" ma:internalName="MediaServiceOCR" ma:readOnly="true">
       <xsd:simpleType>
         <xsd:restriction base="dms:Note">
           <xsd:maxLength value="255"/>
         </xsd:restriction>
       </xsd:simpleType>
     </xsd:element>
-    <xsd:element name="MediaServiceGenerationTime" ma:index="17" nillable="true" ma:displayName="MediaServiceGenerationTime" ma:hidden="true" ma:internalName="MediaServiceGenerationTime" ma:readOnly="true">
+    <xsd:element name="MediaServiceGenerationTime" ma:index="16" nillable="true" ma:displayName="MediaServiceGenerationTime" ma:hidden="true" ma:internalName="MediaServiceGenerationTime" ma:readOnly="true">
       <xsd:simpleType>
         <xsd:restriction base="dms:Text"/>
       </xsd:simpleType>
     </xsd:element>
-    <xsd:element name="MediaServiceEventHashCode" ma:index="18" nillable="true" ma:displayName="MediaServiceEventHashCode" ma:hidden="true" ma:internalName="MediaServiceEventHashCode" ma:readOnly="true">
+    <xsd:element name="MediaServiceEventHashCode" ma:index="17" nillable="true" ma:displayName="MediaServiceEventHashCode" ma:hidden="true" ma:internalName="MediaServiceEventHashCode" ma:readOnly="true">
       <xsd:simpleType>
         <xsd:restriction base="dms:Text"/>
+      </xsd:simpleType>
+    </xsd:element>
+    <xsd:element name="InformationClassification" ma:index="18" nillable="true" ma:displayName="Information Classification" ma:default="Internal - Confidential" ma:format="Dropdown" ma:internalName="InformationClassification">
+      <xsd:simpleType>
+        <xsd:restriction base="dms:Choice">
+          <xsd:enumeration value="Internal - Confidential"/>
+          <xsd:enumeration value="External - Confidential"/>
+          <xsd:enumeration value="Public"/>
+        </xsd:restriction>
       </xsd:simpleType>
     </xsd:element>
     <xsd:element name="MediaLengthInSeconds" ma:index="19" nillable="true" ma:displayName="MediaLengthInSeconds" ma:hidden="true" ma:internalName="MediaLengthInSeconds" ma:readOnly="true">
@@ -12936,30 +12937,11 @@
         <xsd:restriction base="dms:Unknown"/>
       </xsd:simpleType>
     </xsd:element>
-    <xsd:element name="MediaServiceBillingMetadata" ma:index="20" nillable="true" ma:displayName="MediaServiceBillingMetadata" ma:hidden="true" ma:internalName="MediaServiceBillingMetadata" ma:readOnly="true">
-      <xsd:simpleType>
-        <xsd:restriction base="dms:Note"/>
-      </xsd:simpleType>
-    </xsd:element>
-    <xsd:element name="MediaServiceLocation" ma:index="21" nillable="true" ma:displayName="Location" ma:indexed="true" ma:internalName="MediaServiceLocation" ma:readOnly="true">
-      <xsd:simpleType>
-        <xsd:restriction base="dms:Text"/>
-      </xsd:simpleType>
-    </xsd:element>
-    <xsd:element name="InformationClassification" ma:index="22" nillable="true" ma:displayName="Information Classification" ma:default="Internal – Confidential" ma:description="To Classify our documents in our site" ma:format="Dropdown" ma:internalName="InformationClassification">
-      <xsd:simpleType>
-        <xsd:restriction base="dms:Choice">
-          <xsd:enumeration value="Internal – Confidential"/>
-          <xsd:enumeration value="Internal – General"/>
-          <xsd:enumeration value="External – Confidential"/>
-        </xsd:restriction>
-      </xsd:simpleType>
-    </xsd:element>
   </xsd:schema>
-  <xsd:schema xmlns:xsd="http://www.w3.org/2001/XMLSchema" xmlns:xs="http://www.w3.org/2001/XMLSchema" xmlns:dms="http://schemas.microsoft.com/office/2006/documentManagement/types" xmlns:pc="http://schemas.microsoft.com/office/infopath/2007/PartnerControls" targetNamespace="40f00ef8-db8f-4715-8532-1d4398c0116e" elementFormDefault="qualified">
+  <xsd:schema xmlns:xsd="http://www.w3.org/2001/XMLSchema" xmlns:xs="http://www.w3.org/2001/XMLSchema" xmlns:dms="http://schemas.microsoft.com/office/2006/documentManagement/types" xmlns:pc="http://schemas.microsoft.com/office/infopath/2007/PartnerControls" targetNamespace="5b5294e1-9b14-479f-be65-1200265709b9" elementFormDefault="qualified">
     <xsd:import namespace="http://schemas.microsoft.com/office/2006/documentManagement/types"/>
     <xsd:import namespace="http://schemas.microsoft.com/office/infopath/2007/PartnerControls"/>
-    <xsd:element name="TaxCatchAll" ma:index="14" nillable="true" ma:displayName="Taxonomy Catch All Column" ma:hidden="true" ma:list="{d11d4fcf-8f08-4598-9b53-906d41f72bd9}" ma:internalName="TaxCatchAll" ma:showField="CatchAllData" ma:web="40f00ef8-db8f-4715-8532-1d4398c0116e">
+    <xsd:element name="TaxCatchAll" ma:index="14" nillable="true" ma:displayName="Taxonomy Catch All Column" ma:hidden="true" ma:list="{c0f0de05-ede7-4a46-9e41-f1e1e405c4b4}" ma:internalName="TaxCatchAll" ma:showField="CatchAllData" ma:web="5b5294e1-9b14-479f-be65-1200265709b9">
       <xsd:complexType>
         <xsd:complexContent>
           <xsd:extension base="dms:MultiChoiceLookup">
@@ -13073,11 +13055,11 @@
 <file path=customXml/item2.xml><?xml version="1.0" encoding="utf-8"?>
 <p:properties xmlns:p="http://schemas.microsoft.com/office/2006/metadata/properties" xmlns:xsi="http://www.w3.org/2001/XMLSchema-instance" xmlns:pc="http://schemas.microsoft.com/office/infopath/2007/PartnerControls">
   <documentManagement>
-    <TaxCatchAll xmlns="40f00ef8-db8f-4715-8532-1d4398c0116e" xsi:nil="true"/>
-    <lcf76f155ced4ddcb4097134ff3c332f xmlns="4d3ef53e-8156-4ea7-b096-a070a847f892">
+    <TaxCatchAll xmlns="5b5294e1-9b14-479f-be65-1200265709b9" xsi:nil="true"/>
+    <lcf76f155ced4ddcb4097134ff3c332f xmlns="4aba8e23-181e-4a95-9270-5fdb07633be2">
       <Terms xmlns="http://schemas.microsoft.com/office/infopath/2007/PartnerControls"/>
     </lcf76f155ced4ddcb4097134ff3c332f>
-    <InformationClassification xmlns="4d3ef53e-8156-4ea7-b096-a070a847f892">Internal – Confidential</InformationClassification>
+    <InformationClassification xmlns="4aba8e23-181e-4a95-9270-5fdb07633be2">Internal – Confidential</InformationClassification>
   </documentManagement>
 </p:properties>
 </file>
@@ -13092,22 +13074,7 @@
 </file>
 
 <file path=customXml/itemProps1.xml><?xml version="1.0" encoding="utf-8"?>
-<ds:datastoreItem xmlns:ds="http://schemas.openxmlformats.org/officeDocument/2006/customXml" ds:itemID="{BDEA9806-2131-450A-8BAB-0E898B2E3FB5}">
-  <ds:schemaRefs>
-    <ds:schemaRef ds:uri="http://schemas.microsoft.com/office/2006/metadata/contentType"/>
-    <ds:schemaRef ds:uri="http://schemas.microsoft.com/office/2006/metadata/properties/metaAttributes"/>
-    <ds:schemaRef ds:uri="http://www.w3.org/2001/XMLSchema"/>
-    <ds:schemaRef ds:uri="http://schemas.microsoft.com/office/2006/metadata/properties"/>
-    <ds:schemaRef ds:uri="4d3ef53e-8156-4ea7-b096-a070a847f892"/>
-    <ds:schemaRef ds:uri="40f00ef8-db8f-4715-8532-1d4398c0116e"/>
-    <ds:schemaRef ds:uri="http://schemas.microsoft.com/office/2006/documentManagement/types"/>
-    <ds:schemaRef ds:uri="http://schemas.microsoft.com/office/infopath/2007/PartnerControls"/>
-    <ds:schemaRef ds:uri="http://schemas.openxmlformats.org/package/2006/metadata/core-properties"/>
-    <ds:schemaRef ds:uri="http://purl.org/dc/elements/1.1/"/>
-    <ds:schemaRef ds:uri="http://purl.org/dc/terms/"/>
-    <ds:schemaRef ds:uri="http://schemas.microsoft.com/internal/obd"/>
-  </ds:schemaRefs>
-</ds:datastoreItem>
+<ds:datastoreItem xmlns:ds="http://schemas.openxmlformats.org/officeDocument/2006/customXml" ds:itemID="{F0DD0E30-55CE-49A2-B039-4D14E07BECDA}"/>
 </file>
 
 <file path=customXml/itemProps2.xml><?xml version="1.0" encoding="utf-8"?>

</xml_diff>